<commit_message>
Control 3 y TIG final: correcciones de la auditoría de la presentación 1
Sin «VRIO» (el instrumento 05 es detección de competencias centrales);
vía legal en condicional («si el reglamento sigue al borrador»); E1 da
ventaja temporal; seguridad «por diseño»; debilidades internas (sin
técnicos habilitados, compras sin cobertura cambiaria); financiamiento como
facilitador, no condición de entrada; LFP como promedio mundial; seguros y
competencia sin afirmaciones absolutas. Porter: posponer se mantiene como
sustituto, con su fundamento en el guion. Guion de nuevo en 13:50.

Co-Authored-By: Claude Opus 5.5 <noreply@anthropic.com>
</commit_message>
<xml_diff>
--- a/control-3/Lumine_Control3_Avance1_TIG.pptx
+++ b/control-3/Lumine_Control3_Avance1_TIG.pptx
@@ -157,7 +157,7 @@
   <p:extLst>
     <p:ext uri="{521415D9-36F7-43E2-AB2F-B90AF26B5E84}">
       <p14:sectionLst xmlns:p14="http://schemas.microsoft.com/office/powerpoint/2010/main">
-        <p14:section name="1 · Diego Alarcón" id="{96b42737-ae54-9e94-de4c-3f75595fb98d}">
+        <p14:section name="1 · Diego Alarcón" id="{9e43aec3-48be-fc3e-a829-5480d2703ac0}">
           <p14:sldIdLst>
             <p14:sldId id="256"/>
             <p14:sldId id="257"/>
@@ -166,14 +166,14 @@
             <p14:sldId id="260"/>
           </p14:sldIdLst>
         </p14:section>
-        <p14:section name="2 · Benjamín Torres" id="{c275132d-266a-6c70-cc38-aca5d347d48e}">
+        <p14:section name="2 · Benjamín Torres" id="{68a8048f-4493-3af9-b79f-197aef8b2830}">
           <p14:sldIdLst>
             <p14:sldId id="261"/>
             <p14:sldId id="262"/>
             <p14:sldId id="263"/>
           </p14:sldIdLst>
         </p14:section>
-        <p14:section name="3 · Lukas Verdugo" id="{8abea7ac-e95a-b199-5e94-789499c4d6cd}">
+        <p14:section name="3 · Lukas Verdugo" id="{b5885382-b5db-baf7-7b99-f865619491d6}">
           <p14:sldIdLst>
             <p14:sldId id="264"/>
             <p14:sldId id="265"/>
@@ -181,12 +181,12 @@
             <p14:sldId id="267"/>
           </p14:sldIdLst>
         </p14:section>
-        <p14:section name="4 · Diego Alarcón" id="{8f0abdd2-b51f-3b30-37be-46fd3c880173}">
+        <p14:section name="4 · Diego Alarcón" id="{855974be-e500-a379-6b34-08cb4d67ed13}">
           <p14:sldIdLst>
             <p14:sldId id="268"/>
           </p14:sldIdLst>
         </p14:section>
-        <p14:section name="Anexo" id="{76a9a137-c672-386b-fba7-ab8f868cdec1}">
+        <p14:section name="Anexo" id="{d4a2444a-016b-55af-04d0-2fa72715c38d}">
           <p14:sldIdLst>
             <p14:sldId id="269"/>
             <p14:sldId id="270"/>
@@ -1181,8 +1181,8 @@
           <a:p>
             <a:r>
               <a:rPr lang="en-US" dirty="0"/>
-              <a:t>LUKAS VERDUGO · 1:15 a 130 palabras por minuto (162 palabras) · Informe: 6.5 Síntesis FODA
-El FODA ordena todo lo anterior, separando lo interno de lo externo. Las fortalezas son de diseño: una arquitectura en el eje trasero que conserva el motor, un proceso de taller de cinco etapas y un segmento definido. Las debilidades son de ejecución: sin ensayo ni homologación, una biblioteca vacía, técnicos escasos, inventario en dólares sin cobertura y una marca sin casos. Cuidamos no repetir factores: el dólar aparece como amenaza externa y su efecto interno, el inventario sin cobertura, como debilidad. Afuera, las oportunidades son reales y medibles: el parque se conserva, la bencina subió y las baterías se abaratan. Pero las amenazas son decisivas: la ley sin reglamento, el dólar alto con un kit importado, el menor ingreso disponible de los hogares y la opción del cliente de posponer la compra. La lectura es clara: el entorno ofrece una necesidad, pero el negocio todavía no tiene cómo demostrar que la resuelve de forma legal, segura y conveniente para el cliente.</a:t>
+              <a:t>LUKAS VERDUGO · 1:15 a 130 palabras por minuto (163 palabras) · Informe: 6.5 Síntesis FODA
+El FODA ordena todo lo anterior, separando lo interno de lo externo. Las fortalezas son de diseño: una arquitectura en el eje trasero que conserva el motor, un proceso de taller de cinco etapas y un segmento definido. Las debilidades son de ejecución: sin ensayo ni homologación, una biblioteca vacía, sin técnicos habilitados, compras en dólares sin cobertura y una marca sin casos. Cuidamos no repetir factores: el dólar aparece como amenaza externa y su efecto interno, las compras sin cobertura, como debilidad. Afuera, las oportunidades son reales y medibles: el parque se conserva, la bencina subió y las baterías se abaratan. Pero las amenazas son decisivas: la ley sin reglamento, el dólar alto con un kit importado, el menor ingreso disponible de los hogares y la opción del cliente de posponer la compra. La lectura es clara: el entorno ofrece una necesidad, pero el negocio todavía no tiene cómo demostrar que la resuelve de forma legal, segura y conveniente para el cliente.</a:t>
             </a:r>
             <a:endParaRPr lang="en-US" dirty="0"/>
           </a:p>
@@ -1804,7 +1804,7 @@
             <a:r>
               <a:rPr lang="en-US" dirty="0"/>
               <a:t>ANEXO A4 · Solo si preguntan.
-Seis factores con su habilidad y su riesgo, de 1 a 5; dos son condiciones de entrada.</a:t>
+Seis factores con su habilidad y su riesgo, de 1 a 5; la gestión regulatoria es condición de entrada.</a:t>
             </a:r>
             <a:endParaRPr lang="en-US" dirty="0"/>
           </a:p>
@@ -2604,8 +2604,8 @@
           <a:p>
             <a:r>
               <a:rPr lang="en-US" dirty="0"/>
-              <a:t>DIEGO ALARCÓN · 0:55 a 130 palabras por minuto (120 palabras) · Informe: 4. Comprensión del negocio
-Lumine Motors Chile es un proyecto, todavía sin operación, que instalaría un kit de hibridación aditiva en autos a combustión de tracción delantera. El motor original, la transmisión y la alimentación quedan como están. El kit suma tres piezas: una unidad de control, que decide cuándo asistir y corta ante fallas; un banco de baterías, que guarda la energía que hoy se pierde al frenar; y un motor eléctrico en el eje trasero, que ayuda al auto a moverse. No se enchufa, y el freno, el ABS y el control de estabilidad originales siempre mandan sobre el kit. Todavía es un diseño: falta probarlo, homologarlo y documentarlo antes de ofrecerlo. Por eso hoy no hablamos de resultados, sino de condiciones.</a:t>
+              <a:t>DIEGO ALARCÓN · 0:55 a 130 palabras por minuto (124 palabras) · Informe: 4. Comprensión del negocio
+Lumine Motors Chile es un proyecto, todavía sin operación, que instalaría un kit de hibridación aditiva en autos a combustión de tracción delantera. El motor original, la transmisión y la alimentación quedan como están. El kit suma tres piezas: una unidad de control, que decide cuándo asistir y corta ante fallas; un banco de baterías, que guarda la energía que hoy se pierde al frenar; y un motor eléctrico en el eje trasero, que ayuda al auto a moverse. No se enchufa, y el diseño deja que el freno, el ABS y el control de estabilidad originales siempre manden sobre el kit. Todavía es un diseño: falta probarlo, homologarlo y documentarlo antes de ofrecerlo. Por eso hoy no hablamos de resultados, sino de condiciones.</a:t>
             </a:r>
             <a:endParaRPr lang="en-US" dirty="0"/>
           </a:p>
@@ -2871,8 +2871,8 @@
           <a:p>
             <a:r>
               <a:rPr lang="en-US" dirty="0"/>
-              <a:t>BENJAMÍN TORRES · 1:30 a 130 palabras por minuto (197 palabras) · Informe: 6.2 Entorno general: PEST
-Gracias, Diego. Para el entorno general usamos la matriz PEST del curso. Cada factor se califica de uno a cinco, donde tres es neutro; bajo tres, el entorno juega en contra. El resultado global es dos coma ochenta y dos: un entorno moderadamente desfavorable. De cincuenta y un factores, trece son oportunidades, dieciocho son neutros y veinte son amenazas. Pero la lectura no es solo el número, sino su composición: lo importante es dónde está el freno. La dimensión económica es la más baja, con dos coma treinta y ocho: el ingreso disponible de los hogares cayó con el alza de los combustibles, el desempleo llegó a nueve coma seis por ciento y el kit es cien por ciento importado, con un dólar sobre novecientos setenta pesos. La segunda más baja es la político-jurídica, con dos coma sesenta y siete, por la regulación que explico enseguida. En cambio, la tecnológica es la más favorable, con tres coma veintitrés: los componentes son maduros y las baterías LFP llegaron a ochenta y un dólares por kilowatt hora, según BloombergNEF. Es decir: la tecnología existe; lo que falta es que el cliente pueda pagarla y que la ley permita instalarla.</a:t>
+              <a:t>BENJAMÍN TORRES · 1:30 a 130 palabras por minuto (190 palabras) · Informe: 6.2 Entorno general: PEST
+Gracias, Diego. Para el entorno general usamos la matriz PEST del curso. Cada factor se califica de uno a cinco, donde tres es neutro; bajo tres, el entorno juega en contra. El resultado global es dos coma ochenta y dos: un entorno moderadamente desfavorable. De cincuenta y un factores, trece son oportunidades, dieciocho son neutros y veinte son amenazas. Pero lo importante es dónde está el freno. La dimensión económica es la más baja, con dos coma treinta y ocho: el ingreso de los hogares cayó con el alza de los combustibles, el desempleo llegó a nueve coma seis por ciento y el kit es cien por ciento importado, con un dólar sobre novecientos setenta pesos. La segunda más baja es la político-jurídica, con dos coma sesenta y siete, por la regulación. En cambio, la tecnológica es la más favorable, con tres coma veintitrés: los componentes son maduros y el precio promedio mundial de los paquetes de baterías LFP llegó a ochenta y un dólares por kilowatt hora, según BloombergNEF. Es decir: la tecnología existe; lo que falta es que el cliente pueda pagarla y que la ley permita instalarla.</a:t>
             </a:r>
             <a:endParaRPr lang="en-US" dirty="0"/>
           </a:p>
@@ -2960,8 +2960,8 @@
           <a:p>
             <a:r>
               <a:rPr lang="en-US" dirty="0"/>
-              <a:t>BENJAMÍN TORRES · 1:20 a 130 palabras por minuto (173 palabras) · Informe: 6.2 Entorno general: PEST (regulación)
-La regulación merece una lámina propia, porque decide si el negocio existe. La Ley veintiún mil setecientos noventa y tres, publicada el catorce de enero de este año, facultó al Ministerio de Transportes para autorizar talleres que transformen la propulsión de vehículos en uso. Pero todavía no tiene reglamento. La única referencia es un borrador de diciembre de dos mil veintiuno, anterior a la ley, que define la transformación como reemplazar el motor por uno eléctrico y excluye autos con ABS, airbag o control de estabilidad. Con esas dos preguntas armamos cuatro escenarios. Si el reglamento acepta conservar el motor y no excluye esos sistemas, hay una vía amplia que protege al primero que homologa. Si los excluye, la vía queda acotada. Si no acepta conservar el motor, queda una vía alternativa, por alteración de características, o ninguna, y entonces el negocio no opera. Con el borrador actual, Lumine está en la rama de los escenarios tres o cuatro. No es una amenaza que se promedie con otras: es una condición de entrada.</a:t>
+              <a:t>BENJAMÍN TORRES · 1:25 a 130 palabras por minuto (181 palabras) · Informe: 6.2 Entorno general: PEST (regulación)
+La regulación decide si el negocio existe. La Ley veintiún mil setecientos noventa y tres, publicada el catorce de enero de este año, facultó al Ministerio de Transportes para autorizar talleres que transformen la propulsión de vehículos en uso. Pero todavía no tiene reglamento. La única referencia es un borrador de diciembre de dos mil veintiuno, anterior a la ley, que define la transformación como reemplazar el motor por uno eléctrico y excluye autos con ABS, airbag o control de estabilidad. Con esas dos preguntas armamos cuatro escenarios. Si el reglamento acepta conservar el motor y no excluye esos sistemas, hay una vía amplia, en la que el primero que homologa gana una ventaja temporal. Si los excluye, la vía queda acotada. Si no acepta conservar el motor, queda una vía alternativa, por alteración de características, o ninguna, y entonces el negocio no opera. Si el reglamento sigue al borrador, Lumine quedaría en la rama de los escenarios tres o cuatro; la vía aplicable está sin confirmar. No es una amenaza que se promedie con otras: es una condición de entrada.</a:t>
             </a:r>
             <a:endParaRPr lang="en-US" dirty="0"/>
           </a:p>
@@ -3049,8 +3049,8 @@
           <a:p>
             <a:r>
               <a:rPr lang="en-US" dirty="0"/>
-              <a:t>BENJAMÍN TORRES · 1:40 a 130 palabras por minuto (217 palabras) · Informe: 6.3 Industria: cinco fuerzas
-Para la industria usamos las cinco fuerzas de Porter. Cada fuerza se califica de cero a cinco según su intensidad, y el modelo pondera su importancia. El resultado ponderado es tres coma cuarenta y nueve: una industria moderadamente poco atractiva. La fuerza más intensa son los sustitutos, con el máximo de cinco. Y el sustituto principal no es otro taller: es posponer la inversión. Si el cliente no compra el kit, se ahorra ese desembolso, pero sigue pagando toda su bencina. También compiten el híbrido usado y otras formas de reconversión. Le siguen los nuevos entrantes, con tres coma setenta y cinco: hoy la regulación bloquea a todos por igual, pero cuando se abra la vía, cualquiera con presupuesto podría homologar. Los clientes, con dos coma sesenta y cuatro, y los proveedores, con dos coma sesenta y siete, presionan menos, y la rivalidad es baja, uno coma ochenta y tres, porque hoy nadie ofrece este servicio. Ojo con una cifra: sustitutos y clientes suman cincuenta y cinco por ciento de la ponderación del modelo; eso es peso dentro del instrumento, no probabilidad de amenaza. Lo que Lumine sí puede influir es la barrera de entrada, la sensibilidad al precio y la inercia del cliente, con evidencia de ahorro. Lukas sigue con lo que Lumine tiene hacia adentro.</a:t>
+              <a:t>BENJAMÍN TORRES · 1:40 a 130 palabras por minuto (220 palabras) · Informe: 6.3 Industria: cinco fuerzas
+Para la industria usamos las cinco fuerzas de Porter. Cada fuerza se califica de cero a cinco según su intensidad, y el modelo pondera su importancia. El resultado ponderado es tres coma cuarenta y nueve: una industria moderadamente poco atractiva. La fuerza más intensa son los sustitutos, con el máximo de cinco. Y el sustituto principal no es otro taller: es posponer la inversión; el propio Porter cuenta como sustituto la opción de prescindir del producto o comprar usado. Quien no compra se ahorra el kit, pero sigue pagando toda su bencina. También compiten el híbrido usado y otras formas de reconversión. Le siguen los nuevos entrantes, con tres coma setenta y cinco: hoy la regulación bloquea a todos por igual, pero cuando se abra la vía, cualquiera con presupuesto podría homologar. Los clientes, con dos coma sesenta y cuatro, y los proveedores, con dos coma sesenta y siete, presionan menos, y la rivalidad es baja, uno coma ochenta y tres, porque nuestro análisis no identifica competidores directos en hibridación aditiva. Ojo: sustitutos y clientes suman cincuenta y cinco por ciento de la ponderación del modelo; eso es peso dentro del instrumento, no probabilidad de amenaza. Lo que Lumine sí puede mover es la inercia del cliente, con evidencia de ahorro. Lukas sigue con lo que Lumine tiene hacia adentro.</a:t>
             </a:r>
             <a:endParaRPr lang="en-US" dirty="0"/>
           </a:p>
@@ -3138,8 +3138,8 @@
           <a:p>
             <a:r>
               <a:rPr lang="en-US" dirty="0"/>
-              <a:t>LUKAS VERDUGO · 1:15 a 130 palabras por minuto (158 palabras) · Informe: 6.4 Capacidades internas
-Gracias, Benjamín. Hacia adentro, Lumine tiene una fortaleza de diseño, no de ejecución. En el análisis de recursos y capacidades evaluamos quince elementos con cuatro filtros: valioso, raro, costoso de imitar e insustituible. Solo dos pasan los cuatro: la biblioteca de calibraciones por marca y modelo y la ingeniería de integración. Pero hay que leerlo con cuidado: son ventajas potencialmente sostenibles, no efectivas, porque la biblioteca está vacía y solo sería sostenible si se protege como secreto empresarial. Seis elementos dan ventajas temporales y siete solo igualdad. Esto importa porque una ventaja que no se protege ni se demuestra no sostiene un precio. Los factores críticos de éxito muestran lo mismo: la ingeniería de integración y la estandarización del taller tienen habilidad cuatro de cinco, pero como diseño; la gestión regulatoria y el talento en alta tensión están en dos, y el financiamiento en el punto de venta no tiene convenio. Dos de ellos son condiciones de entrada.</a:t>
+              <a:t>LUKAS VERDUGO · 1:10 a 130 palabras por minuto (151 palabras) · Informe: 6.4 Capacidades internas
+Gracias, Benjamín. Hacia adentro, Lumine tiene una fortaleza de diseño, no de ejecución. En el análisis de recursos y capacidades evaluamos quince elementos con cuatro filtros: valioso, raro, costoso de imitar e insustituible. Solo dos pasan los cuatro: la biblioteca de calibraciones por marca y modelo y la ingeniería de integración. Pero hay que leerlo con cuidado: son ventajas potencialmente sostenibles, no efectivas, porque la biblioteca está vacía y solo sería sostenible si se protege como secreto empresarial. Seis elementos dan ventajas temporales y siete solo igualdad. Los factores críticos de éxito muestran lo mismo: la ingeniería de integración y la estandarización del taller tienen habilidad cuatro de cinco, pero como diseño; la gestión regulatoria y el talento en alta tensión están en dos, y el financiamiento en el punto de venta no tiene convenio. La gestión regulatoria es una condición de entrada; el financiamiento, un facilitador clave de la compra.</a:t>
             </a:r>
             <a:endParaRPr lang="en-US" dirty="0"/>
           </a:p>
@@ -4756,7 +4756,7 @@
                 <a:ea typeface="IBM Plex Mono" pitchFamily="34" charset="-122"/>
                 <a:cs typeface="IBM Plex Mono" pitchFamily="34" charset="-120"/>
               </a:rPr>
-              <a:t>09</a:t>
+              <a:t>10</a:t>
             </a:r>
             <a:pPr indent="0" marL="0">
               <a:buNone/>
@@ -6002,7 +6002,7 @@
                 <a:ea typeface="IBM Plex Mono" pitchFamily="34" charset="-122"/>
                 <a:cs typeface="IBM Plex Mono" pitchFamily="34" charset="-120"/>
               </a:rPr>
-              <a:t>10</a:t>
+              <a:t>11</a:t>
             </a:r>
             <a:pPr indent="0" marL="0">
               <a:buNone/>
@@ -6749,7 +6749,7 @@
                 <a:ea typeface="Figtree" pitchFamily="34" charset="-122"/>
                 <a:cs typeface="Figtree" pitchFamily="34" charset="-120"/>
               </a:rPr>
-              <a:t>Técnicos escasos y sin retención</a:t>
+              <a:t>Sin técnicos habilitados ni retención</a:t>
             </a:r>
             <a:endParaRPr lang="es-CL" sz="1600" dirty="0"/>
           </a:p>
@@ -6808,7 +6808,7 @@
                 <a:ea typeface="Figtree" pitchFamily="34" charset="-122"/>
                 <a:cs typeface="Figtree" pitchFamily="34" charset="-120"/>
               </a:rPr>
-              <a:t>Inventario en dólares; marca sin casos</a:t>
+              <a:t>Compras sin cobertura cambiaria; marca sin casos</a:t>
             </a:r>
             <a:endParaRPr lang="es-CL" sz="1600" dirty="0"/>
           </a:p>
@@ -7069,7 +7069,7 @@
                 <a:ea typeface="Figtree" pitchFamily="34" charset="-122"/>
                 <a:cs typeface="Figtree" pitchFamily="34" charset="-120"/>
               </a:rPr>
-              <a:t>Baterías LFP a US$81 por kWh</a:t>
+              <a:t>Packs LFP a US$81/kWh, promedio mundial</a:t>
             </a:r>
             <a:endParaRPr lang="es-CL" sz="1600" dirty="0"/>
           </a:p>
@@ -7444,7 +7444,7 @@
                 <a:ea typeface="IBM Plex Mono" pitchFamily="34" charset="-122"/>
                 <a:cs typeface="IBM Plex Mono" pitchFamily="34" charset="-120"/>
               </a:rPr>
-              <a:t>11</a:t>
+              <a:t>12</a:t>
             </a:r>
             <a:pPr indent="0" marL="0">
               <a:buNone/>
@@ -8638,7 +8638,7 @@
                 <a:ea typeface="IBM Plex Mono" pitchFamily="34" charset="-122"/>
                 <a:cs typeface="IBM Plex Mono" pitchFamily="34" charset="-120"/>
               </a:rPr>
-              <a:t>VIENE DE · VRIO · FCE · CADENA</a:t>
+              <a:t>VIENE DE · RECURSOS · FCE · CADENA</a:t>
             </a:r>
             <a:endParaRPr lang="es-CL" sz="1100" dirty="0"/>
           </a:p>
@@ -8805,7 +8805,7 @@
                 <a:ea typeface="IBM Plex Mono" pitchFamily="34" charset="-122"/>
                 <a:cs typeface="IBM Plex Mono" pitchFamily="34" charset="-120"/>
               </a:rPr>
-              <a:t>12</a:t>
+              <a:t>13</a:t>
             </a:r>
             <a:pPr indent="0" marL="0">
               <a:buNone/>
@@ -12888,7 +12888,7 @@
                 <a:ea typeface="Figtree" pitchFamily="34" charset="-122"/>
                 <a:cs typeface="Figtree" pitchFamily="34" charset="-120"/>
               </a:rPr>
-              <a:t>Bencina más cara; baterías LFP a US$81/kWh</a:t>
+              <a:t>Bencina más cara; packs LFP a US$81/kWh (promedio mundial)</a:t>
             </a:r>
             <a:endParaRPr lang="es-CL" sz="1400" dirty="0"/>
           </a:p>
@@ -13163,7 +13163,7 @@
                 <a:ea typeface="Figtree" pitchFamily="34" charset="-122"/>
                 <a:cs typeface="Figtree" pitchFamily="34" charset="-120"/>
               </a:rPr>
-              <a:t>Aseguradoras excluyen vehículos modificados; pago por sostenibilidad sesgado por ingreso</a:t>
+              <a:t>Posibles exclusiones de modificados en seguros (por verificar); pago por sostenibilidad sesgado por ingreso</a:t>
             </a:r>
             <a:endParaRPr lang="es-CL" sz="1400" dirty="0"/>
           </a:p>
@@ -15302,7 +15302,7 @@
                 <a:ea typeface="Figtree" pitchFamily="34" charset="-122"/>
                 <a:cs typeface="Figtree" pitchFamily="34" charset="-120"/>
               </a:rPr>
-              <a:t>Nadie ofrece hoy el servicio</a:t>
+              <a:t>Sin competidores directos identificados</a:t>
             </a:r>
             <a:endParaRPr lang="es-CL" sz="1600" dirty="0"/>
           </a:p>
@@ -17586,7 +17586,7 @@
                 <a:ea typeface="Instrument Serif" pitchFamily="34" charset="-122"/>
                 <a:cs typeface="Instrument Serif" pitchFamily="34" charset="-120"/>
               </a:rPr>
-              <a:t>dos son condición de entrada.</a:t>
+              <a:t>uno es condición de entrada.</a:t>
             </a:r>
             <a:endParaRPr lang="en-US" sz="3400" dirty="0"/>
           </a:p>
@@ -18163,7 +18163,7 @@
                 <a:ea typeface="Figtree" pitchFamily="34" charset="-122"/>
                 <a:cs typeface="Figtree" pitchFamily="34" charset="-120"/>
               </a:rPr>
-              <a:t>Sin convenio · condición de entrada</a:t>
+              <a:t>Sin convenio · facilitador clave de la compra</a:t>
             </a:r>
             <a:endParaRPr lang="es-CL" sz="1500" dirty="0"/>
           </a:p>
@@ -19676,7 +19676,7 @@
                 <a:ea typeface="IBM Plex Mono" pitchFamily="34" charset="-122"/>
                 <a:cs typeface="IBM Plex Mono" pitchFamily="34" charset="-120"/>
               </a:rPr>
-              <a:t>01</a:t>
+              <a:t>02</a:t>
             </a:r>
             <a:pPr indent="0" marL="0">
               <a:buNone/>
@@ -21325,7 +21325,7 @@
                 <a:ea typeface="Figtree" pitchFamily="34" charset="-122"/>
                 <a:cs typeface="Figtree" pitchFamily="34" charset="-120"/>
               </a:rPr>
-              <a:t>Técnicos escasos y sin esquema de retención</a:t>
+              <a:t>Sin técnicos habilitados ni esquema de retención</a:t>
             </a:r>
             <a:endParaRPr lang="es-CL" sz="1400" dirty="0"/>
           </a:p>
@@ -21346,7 +21346,7 @@
                 <a:ea typeface="Figtree" pitchFamily="34" charset="-122"/>
                 <a:cs typeface="Figtree" pitchFamily="34" charset="-120"/>
               </a:rPr>
-              <a:t>Patrimonio reducido; inventario en dólares sin cobertura</a:t>
+              <a:t>Patrimonio reducido; compras en dólares sin cobertura</a:t>
             </a:r>
             <a:endParaRPr lang="es-CL" sz="1400" dirty="0"/>
           </a:p>
@@ -21516,7 +21516,7 @@
                 <a:ea typeface="Figtree" pitchFamily="34" charset="-122"/>
                 <a:cs typeface="Figtree" pitchFamily="34" charset="-120"/>
               </a:rPr>
-              <a:t>Baterías LFP a US$81/kWh (BloombergNEF, 2025)</a:t>
+              <a:t>Packs LFP a US$81/kWh, promedio mundial (BloombergNEF, 2025)</a:t>
             </a:r>
             <a:endParaRPr lang="es-CL" sz="1400" dirty="0"/>
           </a:p>
@@ -21707,7 +21707,7 @@
                 <a:ea typeface="Figtree" pitchFamily="34" charset="-122"/>
                 <a:cs typeface="Figtree" pitchFamily="34" charset="-120"/>
               </a:rPr>
-              <a:t>Posponer la inversión; aseguradoras excluyen modificados</a:t>
+              <a:t>Posponer la inversión; posibles exclusiones de seguros</a:t>
             </a:r>
             <a:endParaRPr lang="es-CL" sz="1400" dirty="0"/>
           </a:p>
@@ -23771,7 +23771,7 @@
                 <a:ea typeface="Figtree" pitchFamily="34" charset="-122"/>
                 <a:cs typeface="Figtree" pitchFamily="34" charset="-120"/>
               </a:rPr>
-              <a:t>VRIO 2 de 15 y FCE</a:t>
+              <a:t>Recursos: 2 de 15; FCE</a:t>
             </a:r>
             <a:endParaRPr lang="es-CL" sz="1600" dirty="0"/>
           </a:p>
@@ -25634,7 +25634,7 @@
                 <a:ea typeface="Figtree" pitchFamily="34" charset="-122"/>
                 <a:cs typeface="Figtree" pitchFamily="34" charset="-120"/>
               </a:rPr>
-              <a:t>A3 · VRIO · A4 · FCE</a:t>
+              <a:t>A3 · recursos · A4 · FCE</a:t>
             </a:r>
             <a:endParaRPr lang="es-CL" sz="1500" dirty="0"/>
           </a:p>
@@ -29582,7 +29582,7 @@
                 <a:ea typeface="IBM Plex Mono" pitchFamily="34" charset="-122"/>
                 <a:cs typeface="IBM Plex Mono" pitchFamily="34" charset="-120"/>
               </a:rPr>
-              <a:t>02</a:t>
+              <a:t>03</a:t>
             </a:r>
             <a:pPr indent="0" marL="0">
               <a:buNone/>
@@ -30398,7 +30398,7 @@
               <a:buNone/>
             </a:pPr>
             <a:r>
-              <a:rPr lang="es-CL" altLang="en-US" sz="1700" dirty="0">
+              <a:rPr lang="es-CL" altLang="en-US" sz="1600" dirty="0">
                 <a:solidFill>
                   <a:schemeClr val="tx1"/>
                 </a:solidFill>
@@ -30408,7 +30408,7 @@
               </a:rPr>
               <a:t>Preoperativa: sin taller, personal ni clientes</a:t>
             </a:r>
-            <a:endParaRPr lang="es-CL" sz="1700" dirty="0"/>
+            <a:endParaRPr lang="es-CL" sz="1600" dirty="0"/>
           </a:p>
         </p:txBody>
       </p:sp>
@@ -30499,7 +30499,7 @@
               <a:buNone/>
             </a:pPr>
             <a:r>
-              <a:rPr lang="es-CL" altLang="en-US" sz="1700" dirty="0">
+              <a:rPr lang="es-CL" altLang="en-US" sz="1600" dirty="0">
                 <a:solidFill>
                   <a:schemeClr val="tx1"/>
                 </a:solidFill>
@@ -30507,9 +30507,9 @@
                 <a:ea typeface="Figtree" pitchFamily="34" charset="-122"/>
                 <a:cs typeface="Figtree" pitchFamily="34" charset="-120"/>
               </a:rPr>
-              <a:t>Freno, ABS y control de estabilidad originales mandan sobre el kit</a:t>
-            </a:r>
-            <a:endParaRPr lang="es-CL" sz="1700" dirty="0"/>
+              <a:t>Por diseño, freno, ABS y estabilidad originales mandan sobre el kit</a:t>
+            </a:r>
+            <a:endParaRPr lang="es-CL" sz="1600" dirty="0"/>
           </a:p>
         </p:txBody>
       </p:sp>
@@ -30600,7 +30600,7 @@
               <a:buNone/>
             </a:pPr>
             <a:r>
-              <a:rPr lang="es-CL" altLang="en-US" sz="1700" dirty="0">
+              <a:rPr lang="es-CL" altLang="en-US" sz="1600" dirty="0">
                 <a:solidFill>
                   <a:schemeClr val="tx1"/>
                 </a:solidFill>
@@ -30610,7 +30610,7 @@
               </a:rPr>
               <a:t>Falta probarlo, homologarlo y documentarlo</a:t>
             </a:r>
-            <a:endParaRPr lang="es-CL" sz="1700" dirty="0"/>
+            <a:endParaRPr lang="es-CL" sz="1600" dirty="0"/>
           </a:p>
         </p:txBody>
       </p:sp>
@@ -30788,7 +30788,7 @@
                 <a:ea typeface="IBM Plex Mono" pitchFamily="34" charset="-122"/>
                 <a:cs typeface="IBM Plex Mono" pitchFamily="34" charset="-120"/>
               </a:rPr>
-              <a:t>03</a:t>
+              <a:t>04</a:t>
             </a:r>
             <a:pPr indent="0" marL="0">
               <a:buNone/>
@@ -32108,7 +32108,7 @@
                 <a:ea typeface="IBM Plex Mono" pitchFamily="34" charset="-122"/>
                 <a:cs typeface="IBM Plex Mono" pitchFamily="34" charset="-120"/>
               </a:rPr>
-              <a:t>04</a:t>
+              <a:t>05</a:t>
             </a:r>
             <a:pPr indent="0" marL="0">
               <a:buNone/>
@@ -33201,7 +33201,7 @@
                 <a:ea typeface="IBM Plex Mono" pitchFamily="34" charset="-122"/>
                 <a:cs typeface="IBM Plex Mono" pitchFamily="34" charset="-120"/>
               </a:rPr>
-              <a:t>05</a:t>
+              <a:t>06</a:t>
             </a:r>
             <a:pPr indent="0" marL="0">
               <a:buNone/>
@@ -33955,7 +33955,7 @@
                 <a:ea typeface="Figtree" pitchFamily="34" charset="-122"/>
                 <a:cs typeface="Figtree" pitchFamily="34" charset="-120"/>
               </a:rPr>
-              <a:t>Se conserva el auto; aseguradoras excluyen modificados</a:t>
+              <a:t>Se conserva el auto; posibles exclusiones de seguros</a:t>
             </a:r>
             <a:endParaRPr lang="es-CL" sz="1300" dirty="0"/>
           </a:p>
@@ -34112,7 +34112,7 @@
                 <a:ea typeface="Figtree" pitchFamily="34" charset="-122"/>
                 <a:cs typeface="Figtree" pitchFamily="34" charset="-120"/>
               </a:rPr>
-              <a:t>Componentes maduros; LFP a US$81/kWh</a:t>
+              <a:t>Componentes maduros; packs LFP a US$81/kWh, promedio mundial</a:t>
             </a:r>
             <a:endParaRPr lang="es-CL" sz="1300" dirty="0"/>
           </a:p>
@@ -34920,7 +34920,7 @@
                 <a:ea typeface="IBM Plex Mono" pitchFamily="34" charset="-122"/>
                 <a:cs typeface="IBM Plex Mono" pitchFamily="34" charset="-120"/>
               </a:rPr>
-              <a:t>06</a:t>
+              <a:t>07</a:t>
             </a:r>
             <a:pPr indent="0" marL="0">
               <a:buNone/>
@@ -35852,12 +35852,12 @@
           <a:p>
             <a:pPr indent="0" marL="0">
               <a:lnSpc>
-                <a:spcPct val="92000"/>
+                <a:spcPct val="90000"/>
               </a:lnSpc>
               <a:buNone/>
             </a:pPr>
             <a:r>
-              <a:rPr lang="es-CL" altLang="en-US" sz="1400" dirty="0">
+              <a:rPr lang="es-CL" altLang="en-US" sz="1500" dirty="0">
                 <a:solidFill>
                   <a:schemeClr val="tx1"/>
                 </a:solidFill>
@@ -35865,9 +35865,9 @@
                 <a:ea typeface="Figtree" pitchFamily="34" charset="-122"/>
                 <a:cs typeface="Figtree" pitchFamily="34" charset="-120"/>
               </a:rPr>
-              <a:t>Vía amplia: protege al primero que homologa</a:t>
-            </a:r>
-            <a:endParaRPr lang="es-CL" sz="1400" dirty="0"/>
+              <a:t>Vía amplia: ventaja temporal al primero</a:t>
+            </a:r>
+            <a:endParaRPr lang="es-CL" sz="1500" dirty="0"/>
           </a:p>
         </p:txBody>
       </p:sp>
@@ -35978,12 +35978,12 @@
           <a:p>
             <a:pPr indent="0" marL="0">
               <a:lnSpc>
-                <a:spcPct val="92000"/>
+                <a:spcPct val="90000"/>
               </a:lnSpc>
               <a:buNone/>
             </a:pPr>
             <a:r>
-              <a:rPr lang="es-CL" altLang="en-US" sz="1400" dirty="0">
+              <a:rPr lang="es-CL" altLang="en-US" sz="1500" dirty="0">
                 <a:solidFill>
                   <a:schemeClr val="tx1"/>
                 </a:solidFill>
@@ -35993,7 +35993,7 @@
               </a:rPr>
               <a:t>Vía acotada: solo parque sin esos sistemas</a:t>
             </a:r>
-            <a:endParaRPr lang="es-CL" sz="1400" dirty="0"/>
+            <a:endParaRPr lang="es-CL" sz="1500" dirty="0"/>
           </a:p>
         </p:txBody>
       </p:sp>
@@ -36104,12 +36104,12 @@
           <a:p>
             <a:pPr indent="0" marL="0">
               <a:lnSpc>
-                <a:spcPct val="92000"/>
+                <a:spcPct val="90000"/>
               </a:lnSpc>
               <a:buNone/>
             </a:pPr>
             <a:r>
-              <a:rPr lang="es-CL" altLang="en-US" sz="1400" dirty="0">
+              <a:rPr lang="es-CL" altLang="en-US" sz="1500" dirty="0">
                 <a:solidFill>
                   <a:schemeClr val="tx1"/>
                 </a:solidFill>
@@ -36119,7 +36119,7 @@
               </a:rPr>
               <a:t>Vía alternativa: alteración de características</a:t>
             </a:r>
-            <a:endParaRPr lang="es-CL" sz="1400" dirty="0"/>
+            <a:endParaRPr lang="es-CL" sz="1500" dirty="0"/>
           </a:p>
         </p:txBody>
       </p:sp>
@@ -36230,12 +36230,12 @@
           <a:p>
             <a:pPr indent="0" marL="0">
               <a:lnSpc>
-                <a:spcPct val="92000"/>
+                <a:spcPct val="90000"/>
               </a:lnSpc>
               <a:buNone/>
             </a:pPr>
             <a:r>
-              <a:rPr lang="es-CL" altLang="en-US" sz="1400" dirty="0">
+              <a:rPr lang="es-CL" altLang="en-US" sz="1500" dirty="0">
                 <a:solidFill>
                   <a:schemeClr val="tx1"/>
                 </a:solidFill>
@@ -36245,7 +36245,7 @@
               </a:rPr>
               <a:t>Sin vía legal: el negocio no opera</a:t>
             </a:r>
-            <a:endParaRPr lang="es-CL" sz="1400" dirty="0"/>
+            <a:endParaRPr lang="es-CL" sz="1500" dirty="0"/>
           </a:p>
         </p:txBody>
       </p:sp>
@@ -36718,7 +36718,7 @@
                 <a:ea typeface="IBM Plex Mono" pitchFamily="34" charset="-122"/>
                 <a:cs typeface="IBM Plex Mono" pitchFamily="34" charset="-120"/>
               </a:rPr>
-              <a:t>HOY, CON EL BORRADOR:</a:t>
+              <a:t>SI SIGUE EL BORRADOR:</a:t>
             </a:r>
             <a:endParaRPr lang="es-CL" sz="1100" dirty="0"/>
           </a:p>
@@ -36924,7 +36924,7 @@
                 <a:ea typeface="IBM Plex Mono" pitchFamily="34" charset="-122"/>
                 <a:cs typeface="IBM Plex Mono" pitchFamily="34" charset="-120"/>
               </a:rPr>
-              <a:t>07</a:t>
+              <a:t>08</a:t>
             </a:r>
             <a:pPr indent="0" marL="0">
               <a:buNone/>
@@ -38552,7 +38552,7 @@
                 <a:ea typeface="IBM Plex Mono" pitchFamily="34" charset="-122"/>
                 <a:cs typeface="IBM Plex Mono" pitchFamily="34" charset="-120"/>
               </a:rPr>
-              <a:t>08</a:t>
+              <a:t>09</a:t>
             </a:r>
             <a:pPr indent="0" marL="0">
               <a:buNone/>
@@ -38683,7 +38683,7 @@
                 <a:ea typeface="Figtree" pitchFamily="34" charset="-122"/>
                 <a:cs typeface="Figtree" pitchFamily="34" charset="-120"/>
               </a:rPr>
-              <a:t>Fuentes: instrumento 05 del equipo (recursos y capacidades, criterios VRIO) e instrumento 06 del equipo (factores críticos de éxito, escala 1 a 5).</a:t>
+              <a:t>Fuentes: instrumento 05 del equipo (recursos y capacidades, cuatro criterios de competencias centrales) e instrumento 06 del equipo (factores críticos de éxito, escala 1 a 5).</a:t>
             </a:r>
             <a:endParaRPr lang="es-CL" sz="1100" dirty="0"/>
           </a:p>
@@ -38722,7 +38722,7 @@
                 <a:ea typeface="IBM Plex Mono" pitchFamily="34" charset="-122"/>
                 <a:cs typeface="IBM Plex Mono" pitchFamily="34" charset="-120"/>
               </a:rPr>
-              <a:t>VRIO · 15 RECURSOS Y CAPACIDADES</a:t>
+              <a:t>CUATRO CRITERIOS · 15 RECURSOS</a:t>
             </a:r>
             <a:endParaRPr lang="es-CL" sz="1200" dirty="0"/>
           </a:p>
@@ -40137,14 +40137,56 @@
       </p:sp>
       <p:sp>
         <p:nvSpPr>
-          <p:cNvPr id="54" name="Shape 52"/>
-          <p:cNvSpPr/>
-          <p:nvPr/>
-        </p:nvSpPr>
-        <p:spPr>
-          <a:xfrm>
-            <a:off x="5212080" y="4572000"/>
-            <a:ext cx="73152" cy="173736"/>
+          <p:cNvPr id="54" name="Text 52"/>
+          <p:cNvSpPr txBox="1"/>
+          <p:nvPr/>
+        </p:nvSpPr>
+        <p:spPr>
+          <a:xfrm>
+            <a:off x="5394960" y="4407408"/>
+            <a:ext cx="3870655" cy="502920"/>
+          </a:xfrm>
+          <a:prstGeom prst="rect">
+            <a:avLst/>
+          </a:prstGeom>
+          <a:noFill/>
+          <a:ln/>
+        </p:spPr>
+        <p:txBody>
+          <a:bodyPr wrap="square" lIns="0" tIns="0" rIns="0" bIns="0" rtlCol="0" anchor="ctr"/>
+          <a:lstStyle/>
+          <a:p>
+            <a:pPr indent="0" marL="0">
+              <a:lnSpc>
+                <a:spcPct val="92000"/>
+              </a:lnSpc>
+              <a:buNone/>
+            </a:pPr>
+            <a:r>
+              <a:rPr lang="es-CL" altLang="en-US" sz="1600" dirty="0">
+                <a:solidFill>
+                  <a:schemeClr val="tx1"/>
+                </a:solidFill>
+                <a:latin typeface="Figtree" pitchFamily="34" charset="0"/>
+                <a:ea typeface="Figtree" pitchFamily="34" charset="-122"/>
+                <a:cs typeface="Figtree" pitchFamily="34" charset="-120"/>
+              </a:rPr>
+              <a:t>Financiamiento en el punto de venta</a:t>
+            </a:r>
+            <a:endParaRPr lang="es-CL" sz="1600" dirty="0"/>
+          </a:p>
+        </p:txBody>
+      </p:sp>
+      <p:sp>
+        <p:nvSpPr>
+          <p:cNvPr id="55" name="Shape 53"/>
+          <p:cNvSpPr/>
+          <p:nvPr/>
+        </p:nvSpPr>
+        <p:spPr>
+          <a:xfrm>
+            <a:off x="9402775" y="4585716"/>
+            <a:ext cx="146304" cy="146304"/>
           </a:xfrm>
           <a:prstGeom prst="rect">
             <a:avLst/>
@@ -40157,55 +40199,13 @@
       </p:sp>
       <p:sp>
         <p:nvSpPr>
-          <p:cNvPr id="55" name="Text 53"/>
-          <p:cNvSpPr txBox="1"/>
-          <p:nvPr/>
-        </p:nvSpPr>
-        <p:spPr>
-          <a:xfrm>
-            <a:off x="5394960" y="4407408"/>
-            <a:ext cx="3870655" cy="502920"/>
-          </a:xfrm>
-          <a:prstGeom prst="rect">
-            <a:avLst/>
-          </a:prstGeom>
-          <a:noFill/>
-          <a:ln/>
-        </p:spPr>
-        <p:txBody>
-          <a:bodyPr wrap="square" lIns="0" tIns="0" rIns="0" bIns="0" rtlCol="0" anchor="ctr"/>
-          <a:lstStyle/>
-          <a:p>
-            <a:pPr indent="0" marL="0">
-              <a:lnSpc>
-                <a:spcPct val="92000"/>
-              </a:lnSpc>
-              <a:buNone/>
-            </a:pPr>
-            <a:r>
-              <a:rPr lang="es-CL" altLang="en-US" sz="1600" b="1" dirty="0">
-                <a:solidFill>
-                  <a:schemeClr val="tx1"/>
-                </a:solidFill>
-                <a:latin typeface="Figtree" pitchFamily="34" charset="0"/>
-                <a:ea typeface="Figtree" pitchFamily="34" charset="-122"/>
-                <a:cs typeface="Figtree" pitchFamily="34" charset="-120"/>
-              </a:rPr>
-              <a:t>Financiamiento en el punto de venta</a:t>
-            </a:r>
-            <a:endParaRPr lang="es-CL" sz="1600" dirty="0"/>
-          </a:p>
-        </p:txBody>
-      </p:sp>
-      <p:sp>
-        <p:nvSpPr>
           <p:cNvPr id="56" name="Shape 54"/>
           <p:cNvSpPr/>
           <p:nvPr/>
         </p:nvSpPr>
         <p:spPr>
           <a:xfrm>
-            <a:off x="9402775" y="4585716"/>
+            <a:off x="9603943" y="4585716"/>
             <a:ext cx="146304" cy="146304"/>
           </a:xfrm>
           <a:prstGeom prst="rect">
@@ -40225,7 +40225,7 @@
         </p:nvSpPr>
         <p:spPr>
           <a:xfrm>
-            <a:off x="9603943" y="4585716"/>
+            <a:off x="9805111" y="4585716"/>
             <a:ext cx="146304" cy="146304"/>
           </a:xfrm>
           <a:prstGeom prst="rect">
@@ -40245,26 +40245,6 @@
         </p:nvSpPr>
         <p:spPr>
           <a:xfrm>
-            <a:off x="9805111" y="4585716"/>
-            <a:ext cx="146304" cy="146304"/>
-          </a:xfrm>
-          <a:prstGeom prst="rect">
-            <a:avLst/>
-          </a:prstGeom>
-          <a:solidFill>
-            <a:schemeClr val="tx1"/>
-          </a:solidFill>
-          <a:ln/>
-        </p:spPr>
-      </p:sp>
-      <p:sp>
-        <p:nvSpPr>
-          <p:cNvPr id="59" name="Shape 57"/>
-          <p:cNvSpPr/>
-          <p:nvPr/>
-        </p:nvSpPr>
-        <p:spPr>
-          <a:xfrm>
             <a:off x="10006279" y="4585716"/>
             <a:ext cx="146304" cy="146304"/>
           </a:xfrm>
@@ -40279,7 +40259,7 @@
       </p:sp>
       <p:sp>
         <p:nvSpPr>
-          <p:cNvPr id="60" name="Shape 58"/>
+          <p:cNvPr id="59" name="Shape 57"/>
           <p:cNvSpPr/>
           <p:nvPr/>
         </p:nvSpPr>
@@ -40299,7 +40279,7 @@
       </p:sp>
       <p:sp>
         <p:nvSpPr>
-          <p:cNvPr id="61" name="Text 59"/>
+          <p:cNvPr id="60" name="Text 58"/>
           <p:cNvSpPr txBox="1"/>
           <p:nvPr/>
         </p:nvSpPr>
@@ -40338,7 +40318,7 @@
       </p:sp>
       <p:sp>
         <p:nvSpPr>
-          <p:cNvPr id="62" name="Shape 60"/>
+          <p:cNvPr id="61" name="Shape 59"/>
           <p:cNvSpPr/>
           <p:nvPr/>
         </p:nvSpPr>
@@ -40361,7 +40341,7 @@
       </p:sp>
       <p:sp>
         <p:nvSpPr>
-          <p:cNvPr id="63" name="Shape 61"/>
+          <p:cNvPr id="62" name="Shape 60"/>
           <p:cNvSpPr/>
           <p:nvPr/>
         </p:nvSpPr>
@@ -40381,7 +40361,7 @@
       </p:sp>
       <p:sp>
         <p:nvSpPr>
-          <p:cNvPr id="64" name="Text 62"/>
+          <p:cNvPr id="63" name="Text 61"/>
           <p:cNvSpPr txBox="1"/>
           <p:nvPr/>
         </p:nvSpPr>
@@ -40423,7 +40403,7 @@
       </p:sp>
       <p:sp>
         <p:nvSpPr>
-          <p:cNvPr id="65" name="Shape 63"/>
+          <p:cNvPr id="64" name="Shape 62"/>
           <p:cNvSpPr/>
           <p:nvPr/>
         </p:nvSpPr>
@@ -40443,7 +40423,7 @@
       </p:sp>
       <p:sp>
         <p:nvSpPr>
-          <p:cNvPr id="66" name="Shape 64"/>
+          <p:cNvPr id="65" name="Shape 63"/>
           <p:cNvSpPr/>
           <p:nvPr/>
         </p:nvSpPr>
@@ -40463,7 +40443,7 @@
       </p:sp>
       <p:sp>
         <p:nvSpPr>
-          <p:cNvPr id="67" name="Shape 65"/>
+          <p:cNvPr id="66" name="Shape 64"/>
           <p:cNvSpPr/>
           <p:nvPr/>
         </p:nvSpPr>
@@ -40483,7 +40463,7 @@
       </p:sp>
       <p:sp>
         <p:nvSpPr>
-          <p:cNvPr id="68" name="Shape 66"/>
+          <p:cNvPr id="67" name="Shape 65"/>
           <p:cNvSpPr/>
           <p:nvPr/>
         </p:nvSpPr>
@@ -40503,7 +40483,7 @@
       </p:sp>
       <p:sp>
         <p:nvSpPr>
-          <p:cNvPr id="69" name="Shape 67"/>
+          <p:cNvPr id="68" name="Shape 66"/>
           <p:cNvSpPr/>
           <p:nvPr/>
         </p:nvSpPr>
@@ -40523,7 +40503,7 @@
       </p:sp>
       <p:sp>
         <p:nvSpPr>
-          <p:cNvPr id="70" name="Text 68"/>
+          <p:cNvPr id="69" name="Text 67"/>
           <p:cNvSpPr txBox="1"/>
           <p:nvPr/>
         </p:nvSpPr>
@@ -40562,7 +40542,7 @@
       </p:sp>
       <p:sp>
         <p:nvSpPr>
-          <p:cNvPr id="71" name="Shape 69"/>
+          <p:cNvPr id="70" name="Shape 68"/>
           <p:cNvSpPr/>
           <p:nvPr/>
         </p:nvSpPr>
@@ -40585,7 +40565,7 @@
       </p:sp>
       <p:sp>
         <p:nvSpPr>
-          <p:cNvPr id="72" name="Text 70"/>
+          <p:cNvPr id="71" name="Text 69"/>
           <p:cNvSpPr txBox="1"/>
           <p:nvPr/>
         </p:nvSpPr>
@@ -40627,7 +40607,7 @@
       </p:sp>
       <p:sp>
         <p:nvSpPr>
-          <p:cNvPr id="73" name="Shape 71"/>
+          <p:cNvPr id="72" name="Shape 70"/>
           <p:cNvSpPr/>
           <p:nvPr/>
         </p:nvSpPr>
@@ -40647,7 +40627,7 @@
       </p:sp>
       <p:sp>
         <p:nvSpPr>
-          <p:cNvPr id="74" name="Shape 72"/>
+          <p:cNvPr id="73" name="Shape 71"/>
           <p:cNvSpPr/>
           <p:nvPr/>
         </p:nvSpPr>
@@ -40667,7 +40647,7 @@
       </p:sp>
       <p:sp>
         <p:nvSpPr>
-          <p:cNvPr id="75" name="Shape 73"/>
+          <p:cNvPr id="74" name="Shape 72"/>
           <p:cNvSpPr/>
           <p:nvPr/>
         </p:nvSpPr>
@@ -40687,7 +40667,7 @@
       </p:sp>
       <p:sp>
         <p:nvSpPr>
-          <p:cNvPr id="76" name="Shape 74"/>
+          <p:cNvPr id="75" name="Shape 73"/>
           <p:cNvSpPr/>
           <p:nvPr/>
         </p:nvSpPr>
@@ -40707,7 +40687,7 @@
       </p:sp>
       <p:sp>
         <p:nvSpPr>
-          <p:cNvPr id="77" name="Shape 75"/>
+          <p:cNvPr id="76" name="Shape 74"/>
           <p:cNvSpPr/>
           <p:nvPr/>
         </p:nvSpPr>
@@ -40727,7 +40707,7 @@
       </p:sp>
       <p:sp>
         <p:nvSpPr>
-          <p:cNvPr id="78" name="Text 76"/>
+          <p:cNvPr id="77" name="Text 75"/>
           <p:cNvSpPr txBox="1"/>
           <p:nvPr/>
         </p:nvSpPr>
@@ -40766,7 +40746,7 @@
       </p:sp>
       <p:sp>
         <p:nvSpPr>
-          <p:cNvPr id="79" name="Shape 77"/>
+          <p:cNvPr id="78" name="Shape 76"/>
           <p:cNvSpPr/>
           <p:nvPr/>
         </p:nvSpPr>
@@ -40789,7 +40769,7 @@
       </p:sp>
       <p:sp>
         <p:nvSpPr>
-          <p:cNvPr id="80" name="Shape 78"/>
+          <p:cNvPr id="79" name="Shape 77"/>
           <p:cNvSpPr/>
           <p:nvPr/>
         </p:nvSpPr>
@@ -40809,7 +40789,7 @@
       </p:sp>
       <p:sp>
         <p:nvSpPr>
-          <p:cNvPr id="81" name="Text 79"/>
+          <p:cNvPr id="80" name="Text 78"/>
           <p:cNvSpPr txBox="1"/>
           <p:nvPr/>
         </p:nvSpPr>

</xml_diff>

<commit_message>
Control 3: cadena de valor en tarjetas y guion del anexo CMI
Lámina 10: actividades primarias como tarjetas (directriz de costo en
blanco, cuello de botella en celeste), según la referencia del equipo.
Guion del anexo A11 (CMI) en guion.js: va a las notas de A11, a GUION.md
y a un Word propio (guion-anexo-docx.js).

Co-Authored-By: Claude Opus 5.5 <noreply@anthropic.com>
</commit_message>
<xml_diff>
--- a/control-3/Lumine_Control3_Avance1_TIG.pptx
+++ b/control-3/Lumine_Control3_Avance1_TIG.pptx
@@ -157,7 +157,7 @@
   <p:extLst>
     <p:ext uri="{521415D9-36F7-43E2-AB2F-B90AF26B5E84}">
       <p14:sectionLst xmlns:p14="http://schemas.microsoft.com/office/powerpoint/2010/main">
-        <p14:section name="1 · Diego Alarcón" id="{9e43aec3-48be-fc3e-a829-5480d2703ac0}">
+        <p14:section name="1 · Diego Alarcón" id="{c07ec2f7-96a1-c293-5a44-db64e6418ba8}">
           <p14:sldIdLst>
             <p14:sldId id="256"/>
             <p14:sldId id="257"/>
@@ -166,14 +166,14 @@
             <p14:sldId id="260"/>
           </p14:sldIdLst>
         </p14:section>
-        <p14:section name="2 · Benjamín Torres" id="{68a8048f-4493-3af9-b79f-197aef8b2830}">
+        <p14:section name="2 · Benjamín Torres" id="{ba24ffc5-d277-66f7-73bb-7f49bb893e47}">
           <p14:sldIdLst>
             <p14:sldId id="261"/>
             <p14:sldId id="262"/>
             <p14:sldId id="263"/>
           </p14:sldIdLst>
         </p14:section>
-        <p14:section name="3 · Lukas Verdugo" id="{b5885382-b5db-baf7-7b99-f865619491d6}">
+        <p14:section name="3 · Lukas Verdugo" id="{a3071cf5-5a4f-74b2-0ed5-ce82769e822d}">
           <p14:sldIdLst>
             <p14:sldId id="264"/>
             <p14:sldId id="265"/>
@@ -181,12 +181,12 @@
             <p14:sldId id="267"/>
           </p14:sldIdLst>
         </p14:section>
-        <p14:section name="4 · Diego Alarcón" id="{855974be-e500-a379-6b34-08cb4d67ed13}">
+        <p14:section name="4 · Diego Alarcón" id="{c3ded839-a1e7-c434-70f0-b4dd5b7e6667}">
           <p14:sldIdLst>
             <p14:sldId id="268"/>
           </p14:sldIdLst>
         </p14:section>
-        <p14:section name="Anexo" id="{d4a2444a-016b-55af-04d0-2fa72715c38d}">
+        <p14:section name="Anexo" id="{dc81ecbf-4b04-a32c-8136-4db0be25a225}">
           <p14:sldIdLst>
             <p14:sldId id="269"/>
             <p14:sldId id="270"/>
@@ -2516,7 +2516,16 @@
             <a:r>
               <a:rPr lang="en-US" dirty="0"/>
               <a:t>ANEXO A11 · Solo si preguntan.
-Mapa estratégico preliminar: es material de trabajo del siguiente avance.</a:t>
+Mapa estratégico preliminar: es material de trabajo del siguiente avance.
+GUION (Lukas Verdugo, unos 2:38):
+QUÉ ES · Señalar el título de la lámina.
+Este mapa no forma parte del Avance 1: es material de trabajo del Avance 2, y lo traemos como respaldo porque muestra hacia dónde nos lleva el diagnóstico. Es una propuesta preliminar del equipo.
+CÓMO SE LEE · Recorrer el mapa de abajo hacia arriba.
+Se lee de abajo hacia arriba, en las cuatro perspectivas del Cuadro de Mando Integral. Abajo, en aprendizaje, están las capacidades: la biblioteca de calibraciones, los técnicos habilitados, el protocolo de medición y Lumine Habilita. Esas capacidades hacen posibles los procesos: la vía legal, la aprobación de cada par modelo-kit, la instalación segura, la medición y posventa, la réplica en talleres y las alianzas con aseguradoras, plantas de revisión técnica y financieras. Los procesos producen lo que el cliente compra: la promesa técnica cumplida y el ahorro acreditado; de ahí deberían salir la confianza y la captación del segmento. Arriba, en la perspectiva financiera, están el margen por servicio, la expansión con licencias y el objetivo final: obtener rentabilidad por sobre el costo de capital. En total son diecisiete objetivos y veinte relaciones.
+QUÉ DICEN LOS COLORES Y LAS FLECHAS · Señalar la leyenda de líneas, arriba a la derecha.
+La barra de color de cada objetivo indica de qué eje estratégico viene; los que no tienen barra son nuevos. La forma de la flecha dice qué tan sólida es la relación: continua es habilitante; blanca y gruesa es una condición externa, como la vía legal; punteada es una hipótesis que habrá que comprobar con datos. Doce de las veinte relaciones son hipótesis, porque Lumine todavía no opera. Por eso hoy todos los indicadores estarían sin medir, y la vía legal funciona como una compuerta: si no se habilita, se detiene lo que depende de ella.
+CONEXIÓN CON EL DIAGNÓSTICO · Volver al índice del anexo al terminar.
+Cada brecha del diagnóstico tiene aquí su respuesta. La habilitación formal, en la vía legal y las alianzas. El valor frente a posponer la compra, en el protocolo de medición, el ahorro acreditado y la forma de pago que aportan las alianzas. Y la capacidad de ejecución, en la biblioteca, los técnicos y el margen por servicio, que incluye cubrir el riesgo del dólar. Los indicadores, las metas y los responsables de cada objetivo los presentaremos en el Avance 2.</a:t>
             </a:r>
             <a:endParaRPr lang="en-US" dirty="0"/>
           </a:p>
@@ -4902,7 +4911,7 @@
         <p:spPr>
           <a:xfrm>
             <a:off x="548640" y="2350008"/>
-            <a:ext cx="10545775" cy="384048"/>
+            <a:ext cx="10545775" cy="329184"/>
           </a:xfrm>
           <a:prstGeom prst="rect">
             <a:avLst/>
@@ -4927,7 +4936,7 @@
         <p:spPr>
           <a:xfrm>
             <a:off x="713232" y="2350008"/>
-            <a:ext cx="3657600" cy="384048"/>
+            <a:ext cx="3657600" cy="329184"/>
           </a:xfrm>
           <a:prstGeom prst="rect">
             <a:avLst/>
@@ -4966,7 +4975,7 @@
         <p:spPr>
           <a:xfrm>
             <a:off x="4389120" y="2350008"/>
-            <a:ext cx="6522415" cy="384048"/>
+            <a:ext cx="6522415" cy="329184"/>
           </a:xfrm>
           <a:prstGeom prst="rect">
             <a:avLst/>
@@ -5004,8 +5013,8 @@
         </p:nvSpPr>
         <p:spPr>
           <a:xfrm>
-            <a:off x="548640" y="2788920"/>
-            <a:ext cx="10545775" cy="384048"/>
+            <a:off x="548640" y="2734056"/>
+            <a:ext cx="10545775" cy="329184"/>
           </a:xfrm>
           <a:prstGeom prst="rect">
             <a:avLst/>
@@ -5029,8 +5038,8 @@
         </p:nvSpPr>
         <p:spPr>
           <a:xfrm>
-            <a:off x="713232" y="2788920"/>
-            <a:ext cx="3657600" cy="384048"/>
+            <a:off x="713232" y="2734056"/>
+            <a:ext cx="3657600" cy="329184"/>
           </a:xfrm>
           <a:prstGeom prst="rect">
             <a:avLst/>
@@ -5068,8 +5077,8 @@
         </p:nvSpPr>
         <p:spPr>
           <a:xfrm>
-            <a:off x="548640" y="3227832"/>
-            <a:ext cx="10545775" cy="384048"/>
+            <a:off x="548640" y="3118104"/>
+            <a:ext cx="10545775" cy="329184"/>
           </a:xfrm>
           <a:prstGeom prst="rect">
             <a:avLst/>
@@ -5093,8 +5102,8 @@
         </p:nvSpPr>
         <p:spPr>
           <a:xfrm>
-            <a:off x="713232" y="3227832"/>
-            <a:ext cx="3657600" cy="384048"/>
+            <a:off x="713232" y="3118104"/>
+            <a:ext cx="3657600" cy="329184"/>
           </a:xfrm>
           <a:prstGeom prst="rect">
             <a:avLst/>
@@ -5132,8 +5141,8 @@
         </p:nvSpPr>
         <p:spPr>
           <a:xfrm>
-            <a:off x="4389120" y="3227832"/>
-            <a:ext cx="6522415" cy="384048"/>
+            <a:off x="4389120" y="3118104"/>
+            <a:ext cx="6522415" cy="329184"/>
           </a:xfrm>
           <a:prstGeom prst="rect">
             <a:avLst/>
@@ -5171,8 +5180,8 @@
         </p:nvSpPr>
         <p:spPr>
           <a:xfrm>
-            <a:off x="548640" y="3666744"/>
-            <a:ext cx="10545775" cy="384048"/>
+            <a:off x="548640" y="3502152"/>
+            <a:ext cx="10545775" cy="329184"/>
           </a:xfrm>
           <a:prstGeom prst="rect">
             <a:avLst/>
@@ -5196,8 +5205,8 @@
         </p:nvSpPr>
         <p:spPr>
           <a:xfrm>
-            <a:off x="713232" y="3666744"/>
-            <a:ext cx="3657600" cy="384048"/>
+            <a:off x="713232" y="3502152"/>
+            <a:ext cx="3657600" cy="329184"/>
           </a:xfrm>
           <a:prstGeom prst="rect">
             <a:avLst/>
@@ -5235,16 +5244,16 @@
         </p:nvSpPr>
         <p:spPr>
           <a:xfrm>
-            <a:off x="548640" y="4160520"/>
-            <a:ext cx="2218883" cy="1444752"/>
-          </a:xfrm>
-          <a:prstGeom prst="chevron">
+            <a:off x="548640" y="3941064"/>
+            <a:ext cx="1999427" cy="1600200"/>
+          </a:xfrm>
+          <a:prstGeom prst="rect">
             <a:avLst/>
           </a:prstGeom>
           <a:solidFill>
             <a:schemeClr val="bg2"/>
           </a:solidFill>
-          <a:ln w="15875">
+          <a:ln w="19050">
             <a:solidFill>
               <a:schemeClr val="tx1"/>
             </a:solidFill>
@@ -5260,8 +5269,8 @@
         </p:nvSpPr>
         <p:spPr>
           <a:xfrm>
-            <a:off x="914400" y="4251960"/>
-            <a:ext cx="1560515" cy="457200"/>
+            <a:off x="713232" y="4050792"/>
+            <a:ext cx="1725107" cy="548640"/>
           </a:xfrm>
           <a:prstGeom prst="rect">
             <a:avLst/>
@@ -5275,12 +5284,12 @@
           <a:p>
             <a:pPr indent="0" marL="0">
               <a:lnSpc>
-                <a:spcPct val="90000"/>
+                <a:spcPct val="95000"/>
               </a:lnSpc>
               <a:buNone/>
             </a:pPr>
             <a:r>
-              <a:rPr lang="es-CL" altLang="en-US" sz="1400" b="1" dirty="0">
+              <a:rPr lang="es-CL" altLang="en-US" sz="1600" b="1" dirty="0">
                 <a:solidFill>
                   <a:schemeClr val="tx1"/>
                 </a:solidFill>
@@ -5290,7 +5299,7 @@
               </a:rPr>
               <a:t>Logística de entrada</a:t>
             </a:r>
-            <a:endParaRPr lang="es-CL" sz="1400" dirty="0"/>
+            <a:endParaRPr lang="es-CL" sz="1600" dirty="0"/>
           </a:p>
         </p:txBody>
       </p:sp>
@@ -5302,8 +5311,8 @@
         </p:nvSpPr>
         <p:spPr>
           <a:xfrm>
-            <a:off x="914400" y="4782312"/>
-            <a:ext cx="1651955" cy="237744"/>
+            <a:off x="713232" y="4636008"/>
+            <a:ext cx="1725107" cy="384048"/>
           </a:xfrm>
           <a:prstGeom prst="rect">
             <a:avLst/>
@@ -5327,7 +5336,7 @@
                 <a:ea typeface="IBM Plex Mono" pitchFamily="34" charset="-122"/>
                 <a:cs typeface="IBM Plex Mono" pitchFamily="34" charset="-120"/>
               </a:rPr>
-              <a:t>COSTO</a:t>
+              <a:t>DIRECTRIZ DE COSTO</a:t>
             </a:r>
             <a:endParaRPr lang="es-CL" sz="1100" dirty="0"/>
           </a:p>
@@ -5341,8 +5350,8 @@
         </p:nvSpPr>
         <p:spPr>
           <a:xfrm>
-            <a:off x="914400" y="5038344"/>
-            <a:ext cx="1606235" cy="548640"/>
+            <a:off x="713232" y="5038344"/>
+            <a:ext cx="1725107" cy="475488"/>
           </a:xfrm>
           <a:prstGeom prst="rect">
             <a:avLst/>
@@ -5356,12 +5365,12 @@
           <a:p>
             <a:pPr indent="0" marL="0">
               <a:lnSpc>
-                <a:spcPct val="90000"/>
+                <a:spcPct val="95000"/>
               </a:lnSpc>
               <a:buNone/>
             </a:pPr>
             <a:r>
-              <a:rPr lang="es-CL" altLang="en-US" sz="1300" dirty="0">
+              <a:rPr lang="es-CL" altLang="en-US" sz="1400" dirty="0">
                 <a:solidFill>
                   <a:schemeClr val="tx2"/>
                 </a:solidFill>
@@ -5369,9 +5378,9 @@
                 <a:ea typeface="Figtree" pitchFamily="34" charset="-122"/>
                 <a:cs typeface="Figtree" pitchFamily="34" charset="-120"/>
               </a:rPr>
-              <a:t>Kit importado, Clase 9 y dólar</a:t>
-            </a:r>
-            <a:endParaRPr lang="es-CL" sz="1300" dirty="0"/>
+              <a:t>Kit importado, Clase 9, dólar</a:t>
+            </a:r>
+            <a:endParaRPr lang="es-CL" sz="1400" dirty="0"/>
           </a:p>
         </p:txBody>
       </p:sp>
@@ -5383,16 +5392,16 @@
         </p:nvSpPr>
         <p:spPr>
           <a:xfrm>
-            <a:off x="2657795" y="4160520"/>
-            <a:ext cx="2218883" cy="1444752"/>
-          </a:xfrm>
-          <a:prstGeom prst="chevron">
+            <a:off x="2657795" y="3941064"/>
+            <a:ext cx="1999427" cy="1600200"/>
+          </a:xfrm>
+          <a:prstGeom prst="rect">
             <a:avLst/>
           </a:prstGeom>
           <a:solidFill>
             <a:srgbClr val="0B1A22"/>
           </a:solidFill>
-          <a:ln w="15875">
+          <a:ln w="19050">
             <a:solidFill>
               <a:schemeClr val="accent1"/>
             </a:solidFill>
@@ -5408,8 +5417,8 @@
         </p:nvSpPr>
         <p:spPr>
           <a:xfrm>
-            <a:off x="3023555" y="4251960"/>
-            <a:ext cx="1560515" cy="457200"/>
+            <a:off x="2822387" y="4050792"/>
+            <a:ext cx="1725107" cy="548640"/>
           </a:xfrm>
           <a:prstGeom prst="rect">
             <a:avLst/>
@@ -5423,12 +5432,12 @@
           <a:p>
             <a:pPr indent="0" marL="0">
               <a:lnSpc>
-                <a:spcPct val="90000"/>
+                <a:spcPct val="95000"/>
               </a:lnSpc>
               <a:buNone/>
             </a:pPr>
             <a:r>
-              <a:rPr lang="es-CL" altLang="en-US" sz="1400" b="1" dirty="0">
+              <a:rPr lang="es-CL" altLang="en-US" sz="1600" b="1" dirty="0">
                 <a:solidFill>
                   <a:schemeClr val="tx1"/>
                 </a:solidFill>
@@ -5438,7 +5447,7 @@
               </a:rPr>
               <a:t>Operaciones</a:t>
             </a:r>
-            <a:endParaRPr lang="es-CL" sz="1400" dirty="0"/>
+            <a:endParaRPr lang="es-CL" sz="1600" dirty="0"/>
           </a:p>
         </p:txBody>
       </p:sp>
@@ -5450,8 +5459,8 @@
         </p:nvSpPr>
         <p:spPr>
           <a:xfrm>
-            <a:off x="3023555" y="4782312"/>
-            <a:ext cx="1651955" cy="237744"/>
+            <a:off x="2822387" y="4636008"/>
+            <a:ext cx="1725107" cy="384048"/>
           </a:xfrm>
           <a:prstGeom prst="rect">
             <a:avLst/>
@@ -5489,8 +5498,8 @@
         </p:nvSpPr>
         <p:spPr>
           <a:xfrm>
-            <a:off x="3023555" y="5038344"/>
-            <a:ext cx="1606235" cy="548640"/>
+            <a:off x="2822387" y="5038344"/>
+            <a:ext cx="1725107" cy="475488"/>
           </a:xfrm>
           <a:prstGeom prst="rect">
             <a:avLst/>
@@ -5504,12 +5513,12 @@
           <a:p>
             <a:pPr indent="0" marL="0">
               <a:lnSpc>
-                <a:spcPct val="90000"/>
+                <a:spcPct val="95000"/>
               </a:lnSpc>
               <a:buNone/>
             </a:pPr>
             <a:r>
-              <a:rPr lang="es-CL" altLang="en-US" sz="1300" dirty="0">
+              <a:rPr lang="es-CL" altLang="en-US" sz="1400" dirty="0">
                 <a:solidFill>
                   <a:schemeClr val="tx2"/>
                 </a:solidFill>
@@ -5517,9 +5526,9 @@
                 <a:ea typeface="Figtree" pitchFamily="34" charset="-122"/>
                 <a:cs typeface="Figtree" pitchFamily="34" charset="-120"/>
               </a:rPr>
-              <a:t>Homologación, internación y técnicos</a:t>
-            </a:r>
-            <a:endParaRPr lang="es-CL" sz="1300" dirty="0"/>
+              <a:t>Aquí se entrega la exclusividad</a:t>
+            </a:r>
+            <a:endParaRPr lang="es-CL" sz="1400" dirty="0"/>
           </a:p>
         </p:txBody>
       </p:sp>
@@ -5531,10 +5540,10 @@
         </p:nvSpPr>
         <p:spPr>
           <a:xfrm>
-            <a:off x="4766950" y="4160520"/>
-            <a:ext cx="2218883" cy="1444752"/>
-          </a:xfrm>
-          <a:prstGeom prst="chevron">
+            <a:off x="4766950" y="3941064"/>
+            <a:ext cx="1999427" cy="1600200"/>
+          </a:xfrm>
+          <a:prstGeom prst="rect">
             <a:avLst/>
           </a:prstGeom>
           <a:solidFill>
@@ -5556,8 +5565,8 @@
         </p:nvSpPr>
         <p:spPr>
           <a:xfrm>
-            <a:off x="5132710" y="4251960"/>
-            <a:ext cx="1560515" cy="457200"/>
+            <a:off x="4931542" y="4050792"/>
+            <a:ext cx="1725107" cy="548640"/>
           </a:xfrm>
           <a:prstGeom prst="rect">
             <a:avLst/>
@@ -5571,12 +5580,12 @@
           <a:p>
             <a:pPr indent="0" marL="0">
               <a:lnSpc>
-                <a:spcPct val="90000"/>
+                <a:spcPct val="95000"/>
               </a:lnSpc>
               <a:buNone/>
             </a:pPr>
             <a:r>
-              <a:rPr lang="es-CL" altLang="en-US" sz="1400" dirty="0">
+              <a:rPr lang="es-CL" altLang="en-US" sz="1600" b="1" dirty="0">
                 <a:solidFill>
                   <a:schemeClr val="tx1"/>
                 </a:solidFill>
@@ -5586,7 +5595,7 @@
               </a:rPr>
               <a:t>Logística de salida</a:t>
             </a:r>
-            <a:endParaRPr lang="es-CL" sz="1400" dirty="0"/>
+            <a:endParaRPr lang="es-CL" sz="1600" dirty="0"/>
           </a:p>
         </p:txBody>
       </p:sp>
@@ -5598,10 +5607,10 @@
         </p:nvSpPr>
         <p:spPr>
           <a:xfrm>
-            <a:off x="6876105" y="4160520"/>
-            <a:ext cx="2218883" cy="1444752"/>
-          </a:xfrm>
-          <a:prstGeom prst="chevron">
+            <a:off x="6876105" y="3941064"/>
+            <a:ext cx="1999427" cy="1600200"/>
+          </a:xfrm>
+          <a:prstGeom prst="rect">
             <a:avLst/>
           </a:prstGeom>
           <a:solidFill>
@@ -5623,8 +5632,8 @@
         </p:nvSpPr>
         <p:spPr>
           <a:xfrm>
-            <a:off x="7241865" y="4251960"/>
-            <a:ext cx="1560515" cy="457200"/>
+            <a:off x="7040697" y="4050792"/>
+            <a:ext cx="1725107" cy="548640"/>
           </a:xfrm>
           <a:prstGeom prst="rect">
             <a:avLst/>
@@ -5638,12 +5647,12 @@
           <a:p>
             <a:pPr indent="0" marL="0">
               <a:lnSpc>
-                <a:spcPct val="90000"/>
+                <a:spcPct val="95000"/>
               </a:lnSpc>
               <a:buNone/>
             </a:pPr>
             <a:r>
-              <a:rPr lang="es-CL" altLang="en-US" sz="1400" dirty="0">
+              <a:rPr lang="es-CL" altLang="en-US" sz="1600" b="1" dirty="0">
                 <a:solidFill>
                   <a:schemeClr val="tx1"/>
                 </a:solidFill>
@@ -5653,7 +5662,7 @@
               </a:rPr>
               <a:t>Marketing y ventas</a:t>
             </a:r>
-            <a:endParaRPr lang="es-CL" sz="1400" dirty="0"/>
+            <a:endParaRPr lang="es-CL" sz="1600" dirty="0"/>
           </a:p>
         </p:txBody>
       </p:sp>
@@ -5665,10 +5674,10 @@
         </p:nvSpPr>
         <p:spPr>
           <a:xfrm>
-            <a:off x="8985260" y="4160520"/>
-            <a:ext cx="2218883" cy="1444752"/>
-          </a:xfrm>
-          <a:prstGeom prst="chevron">
+            <a:off x="8985260" y="3941064"/>
+            <a:ext cx="1999427" cy="1600200"/>
+          </a:xfrm>
+          <a:prstGeom prst="rect">
             <a:avLst/>
           </a:prstGeom>
           <a:solidFill>
@@ -5690,8 +5699,8 @@
         </p:nvSpPr>
         <p:spPr>
           <a:xfrm>
-            <a:off x="9351020" y="4251960"/>
-            <a:ext cx="1560515" cy="457200"/>
+            <a:off x="9149852" y="4050792"/>
+            <a:ext cx="1725107" cy="548640"/>
           </a:xfrm>
           <a:prstGeom prst="rect">
             <a:avLst/>
@@ -5705,12 +5714,12 @@
           <a:p>
             <a:pPr indent="0" marL="0">
               <a:lnSpc>
-                <a:spcPct val="90000"/>
+                <a:spcPct val="95000"/>
               </a:lnSpc>
               <a:buNone/>
             </a:pPr>
             <a:r>
-              <a:rPr lang="es-CL" altLang="en-US" sz="1400" dirty="0">
+              <a:rPr lang="es-CL" altLang="en-US" sz="1600" b="1" dirty="0">
                 <a:solidFill>
                   <a:schemeClr val="tx1"/>
                 </a:solidFill>
@@ -5720,7 +5729,7 @@
               </a:rPr>
               <a:t>Servicio posventa</a:t>
             </a:r>
-            <a:endParaRPr lang="es-CL" sz="1400" dirty="0"/>
+            <a:endParaRPr lang="es-CL" sz="1600" dirty="0"/>
           </a:p>
         </p:txBody>
       </p:sp>
@@ -5733,7 +5742,7 @@
         <p:spPr>
           <a:xfrm>
             <a:off x="11140135" y="2350008"/>
-            <a:ext cx="502920" cy="3255264"/>
+            <a:ext cx="502920" cy="3191256"/>
           </a:xfrm>
           <a:prstGeom prst="rect">
             <a:avLst/>
@@ -5758,7 +5767,7 @@
         <p:spPr>
           <a:xfrm>
             <a:off x="11140135" y="2350008"/>
-            <a:ext cx="502920" cy="3255264"/>
+            <a:ext cx="502920" cy="3191256"/>
           </a:xfrm>
           <a:prstGeom prst="rect">
             <a:avLst/>
@@ -5796,7 +5805,7 @@
         </p:nvSpPr>
         <p:spPr>
           <a:xfrm>
-            <a:off x="548640" y="5632704"/>
+            <a:off x="548640" y="5568696"/>
             <a:ext cx="11094415" cy="310896"/>
           </a:xfrm>
           <a:prstGeom prst="rect">
@@ -5849,7 +5858,7 @@
         </p:nvSpPr>
         <p:spPr>
           <a:xfrm>
-            <a:off x="548640" y="5961888"/>
+            <a:off x="548640" y="5897880"/>
             <a:ext cx="11094415" cy="310896"/>
           </a:xfrm>
           <a:prstGeom prst="rect">

</xml_diff>

<commit_message>
Control 3: guion del anexo CMI en lenguaje oral (1:56)
Co-Authored-By: Claude Opus 5.5 <noreply@anthropic.com>
</commit_message>
<xml_diff>
--- a/control-3/Lumine_Control3_Avance1_TIG.pptx
+++ b/control-3/Lumine_Control3_Avance1_TIG.pptx
@@ -157,7 +157,7 @@
   <p:extLst>
     <p:ext uri="{521415D9-36F7-43E2-AB2F-B90AF26B5E84}">
       <p14:sectionLst xmlns:p14="http://schemas.microsoft.com/office/powerpoint/2010/main">
-        <p14:section name="1 · Diego Alarcón" id="{c07ec2f7-96a1-c293-5a44-db64e6418ba8}">
+        <p14:section name="1 · Diego Alarcón" id="{b0fcaaf8-6078-abca-b6ea-d8596c61234e}">
           <p14:sldIdLst>
             <p14:sldId id="256"/>
             <p14:sldId id="257"/>
@@ -166,14 +166,14 @@
             <p14:sldId id="260"/>
           </p14:sldIdLst>
         </p14:section>
-        <p14:section name="2 · Benjamín Torres" id="{ba24ffc5-d277-66f7-73bb-7f49bb893e47}">
+        <p14:section name="2 · Benjamín Torres" id="{8ba07021-c769-d4fc-4eba-f51e0e7209c0}">
           <p14:sldIdLst>
             <p14:sldId id="261"/>
             <p14:sldId id="262"/>
             <p14:sldId id="263"/>
           </p14:sldIdLst>
         </p14:section>
-        <p14:section name="3 · Lukas Verdugo" id="{a3071cf5-5a4f-74b2-0ed5-ce82769e822d}">
+        <p14:section name="3 · Lukas Verdugo" id="{0cafde67-2b73-2f7f-2934-32abfea01f97}">
           <p14:sldIdLst>
             <p14:sldId id="264"/>
             <p14:sldId id="265"/>
@@ -181,12 +181,12 @@
             <p14:sldId id="267"/>
           </p14:sldIdLst>
         </p14:section>
-        <p14:section name="4 · Diego Alarcón" id="{c3ded839-a1e7-c434-70f0-b4dd5b7e6667}">
+        <p14:section name="4 · Diego Alarcón" id="{aee75e4c-26d9-5792-992b-a7d26a3ff1ae}">
           <p14:sldIdLst>
             <p14:sldId id="268"/>
           </p14:sldIdLst>
         </p14:section>
-        <p14:section name="Anexo" id="{dc81ecbf-4b04-a32c-8136-4db0be25a225}">
+        <p14:section name="Anexo" id="{f82c7ce7-4807-cf4c-8fea-bcdd4609f15a}">
           <p14:sldIdLst>
             <p14:sldId id="269"/>
             <p14:sldId id="270"/>
@@ -2517,15 +2517,15 @@
               <a:rPr lang="en-US" dirty="0"/>
               <a:t>ANEXO A11 · Solo si preguntan.
 Mapa estratégico preliminar: es material de trabajo del siguiente avance.
-GUION (Lukas Verdugo, unos 2:38):
-QUÉ ES · Señalar el título de la lámina.
-Este mapa no forma parte del Avance 1: es material de trabajo del Avance 2, y lo traemos como respaldo porque muestra hacia dónde nos lleva el diagnóstico. Es una propuesta preliminar del equipo.
-CÓMO SE LEE · Recorrer el mapa de abajo hacia arriba.
-Se lee de abajo hacia arriba, en las cuatro perspectivas del Cuadro de Mando Integral. Abajo, en aprendizaje, están las capacidades: la biblioteca de calibraciones, los técnicos habilitados, el protocolo de medición y Lumine Habilita. Esas capacidades hacen posibles los procesos: la vía legal, la aprobación de cada par modelo-kit, la instalación segura, la medición y posventa, la réplica en talleres y las alianzas con aseguradoras, plantas de revisión técnica y financieras. Los procesos producen lo que el cliente compra: la promesa técnica cumplida y el ahorro acreditado; de ahí deberían salir la confianza y la captación del segmento. Arriba, en la perspectiva financiera, están el margen por servicio, la expansión con licencias y el objetivo final: obtener rentabilidad por sobre el costo de capital. En total son diecisiete objetivos y veinte relaciones.
-QUÉ DICEN LOS COLORES Y LAS FLECHAS · Señalar la leyenda de líneas, arriba a la derecha.
-La barra de color de cada objetivo indica de qué eje estratégico viene; los que no tienen barra son nuevos. La forma de la flecha dice qué tan sólida es la relación: continua es habilitante; blanca y gruesa es una condición externa, como la vía legal; punteada es una hipótesis que habrá que comprobar con datos. Doce de las veinte relaciones son hipótesis, porque Lumine todavía no opera. Por eso hoy todos los indicadores estarían sin medir, y la vía legal funciona como una compuerta: si no se habilita, se detiene lo que depende de ella.
-CONEXIÓN CON EL DIAGNÓSTICO · Volver al índice del anexo al terminar.
-Cada brecha del diagnóstico tiene aquí su respuesta. La habilitación formal, en la vía legal y las alianzas. El valor frente a posponer la compra, en el protocolo de medición, el ahorro acreditado y la forma de pago que aportan las alianzas. Y la capacidad de ejecución, en la biblioteca, los técnicos y el margen por servicio, que incluye cubrir el riesgo del dólar. Los indicadores, las metas y los responsables de cada objetivo los presentaremos en el Avance 2.</a:t>
+GUION (Lukas Verdugo, unos 1:56):
+PARA EMPEZAR · Abrir A11 desde el índice del anexo y señalar el título.
+Profesor, esto que ve aquí es el mapa estratégico de Lumine. No es parte de este avance: es lo que vamos a desarrollar en el Avance 2. Lo dejamos en el anexo porque muestra hacia dónde nos lleva todo el diagnóstico.
+CÓMO SE LEE · Recorrer el mapa con la mano, de abajo hacia arriba.
+El mapa se lee de abajo hacia arriba. Abajo está lo que Lumine tiene que aprender: la biblioteca de calibraciones, los técnicos habilitados y el protocolo para medir el ahorro. Con eso funcionan los procesos: conseguir la vía legal, aprobar cada modelo e instalar de forma segura. Eso le entrega al cliente dos cosas: que el kit cumpla lo que promete y un ahorro que se pueda demostrar. Si lo logramos, viene la confianza, el cliente compra, y arriba, al final, está la meta: que el negocio rinda más de lo que cuesta el capital. En total son diecisiete objetivos, conectados por veinte flechas.
+LAS FLECHAS · Señalar la leyenda de líneas, arriba a la derecha.
+Las flechas no son todas iguales. La continua es algo que tiene que pasar sí o sí antes del paso siguiente. La blanca y gruesa es algo que no depende de nosotros, como la ley. Y la punteada es una hipótesis: creemos que funciona, pero hay que probarlo. Y aquí está lo honesto: doce de las veinte flechas son hipótesis. Es lógico, porque Lumine todavía no opera.
+PARA CERRAR · Volver al índice del anexo.
+Por eso el mapa responde a las tres brechas que vimos: la vía legal, demostrar el ahorro y tener la capacidad de ejecutar. Los indicadores y las metas de cada objetivo los vamos a presentar en el Avance 2.</a:t>
             </a:r>
             <a:endParaRPr lang="en-US" dirty="0"/>
           </a:p>

</xml_diff>